<commit_message>
Add author to deck cover
</commit_message>
<xml_diff>
--- a/deck/SendFast_Q1_2024_Leadership_Review.pptx
+++ b/deck/SendFast_Q1_2024_Leadership_Review.pptx
@@ -2020,6 +2020,46 @@
           </a:p>
         </p:txBody>
       </p:sp>
+      <p:sp>
+        <p:nvSpPr>
+          <p:cNvPr id="6" name="Author"/>
+          <p:cNvSpPr/>
+          <p:nvPr/>
+        </p:nvSpPr>
+        <p:spPr>
+          <a:xfrm>
+            <a:off x="812800" y="5492750"/>
+            <a:ext cx="10883392" cy="285750"/>
+          </a:xfrm>
+          <a:prstGeom prst="rect">
+            <a:avLst/>
+          </a:prstGeom>
+          <a:noFill/>
+          <a:ln/>
+        </p:spPr>
+        <p:txBody>
+          <a:bodyPr wrap="square" lIns="0" tIns="0" rIns="0" bIns="0" rtlCol="0" anchor="t">
+            <a:normAutofit/>
+          </a:bodyPr>
+          <a:lstStyle/>
+          <a:p>
+            <a:pPr algn="l" indent="0" marL="0">
+              <a:buNone/>
+            </a:pPr>
+            <a:r>
+              <a:rPr lang="en-US" sz="1600" b="1" dirty="0">
+                <a:solidFill>
+                  <a:srgbClr val="F7F6F2"/>
+                </a:solidFill>
+                <a:latin typeface="IBM Plex Sans" pitchFamily="34" charset="0"/>
+                <a:ea typeface="IBM Plex Sans" pitchFamily="34" charset="-122"/>
+                <a:cs typeface="IBM Plex Sans" pitchFamily="34" charset="-120"/>
+              </a:rPr>
+              <a:t>Prepared by Frank Azi</a:t>
+            </a:r>
+          </a:p>
+        </p:txBody>
+      </p:sp>
     </p:spTree>
   </p:cSld>
   <p:clrMapOvr>

</xml_diff>